<commit_message>
Updated manuscript and figures
</commit_message>
<xml_diff>
--- a/manuscript/Figures/Blattabacterium HGT_figures-working.pptx
+++ b/manuscript/Figures/Blattabacterium HGT_figures-working.pptx
@@ -5,7 +5,7 @@
     <p:sldMasterId id="2147483648" r:id="rId1"/>
   </p:sldMasterIdLst>
   <p:notesMasterIdLst>
-    <p:notesMasterId r:id="rId12"/>
+    <p:notesMasterId r:id="rId14"/>
   </p:notesMasterIdLst>
   <p:sldIdLst>
     <p:sldId id="256" r:id="rId2"/>
@@ -14,10 +14,12 @@
     <p:sldId id="258" r:id="rId5"/>
     <p:sldId id="257" r:id="rId6"/>
     <p:sldId id="263" r:id="rId7"/>
-    <p:sldId id="261" r:id="rId8"/>
-    <p:sldId id="264" r:id="rId9"/>
-    <p:sldId id="265" r:id="rId10"/>
-    <p:sldId id="260" r:id="rId11"/>
+    <p:sldId id="264" r:id="rId8"/>
+    <p:sldId id="265" r:id="rId9"/>
+    <p:sldId id="266" r:id="rId10"/>
+    <p:sldId id="261" r:id="rId11"/>
+    <p:sldId id="260" r:id="rId12"/>
+    <p:sldId id="267" r:id="rId13"/>
   </p:sldIdLst>
   <p:sldSz cx="12192000" cy="6858000"/>
   <p:notesSz cx="6858000" cy="9144000"/>
@@ -206,7 +208,7 @@
           <a:p>
             <a:fld id="{C4FC65C6-6085-4244-82B2-63B076D03E9C}" type="datetimeFigureOut">
               <a:rPr lang="en-US" smtClean="0"/>
-              <a:t>10/28/25</a:t>
+              <a:t>10/29/25</a:t>
             </a:fld>
             <a:endParaRPr lang="en-US"/>
           </a:p>
@@ -534,15 +536,7 @@
             </a:r>
             <a:r>
               <a:rPr lang="en-US" dirty="0"/>
-              <a:t> for </a:t>
-            </a:r>
-            <a:r>
-              <a:rPr lang="en-US" dirty="0" err="1"/>
-              <a:t>Blattabacterium</a:t>
-            </a:r>
-            <a:r>
-              <a:rPr lang="en-US" dirty="0"/>
-              <a:t> HGT events</a:t>
+              <a:t> for Blattabacterium HGT events</a:t>
             </a:r>
           </a:p>
           <a:p>
@@ -686,15 +680,7 @@
             </a:r>
             <a:r>
               <a:rPr lang="en-US" dirty="0"/>
-              <a:t> for </a:t>
-            </a:r>
-            <a:r>
-              <a:rPr lang="en-US" dirty="0" err="1"/>
-              <a:t>Blattabacterium</a:t>
-            </a:r>
-            <a:r>
-              <a:rPr lang="en-US" dirty="0"/>
-              <a:t> HGT events</a:t>
+              <a:t> for Blattabacterium HGT events</a:t>
             </a:r>
           </a:p>
           <a:p>
@@ -902,68 +888,59 @@
           <a:bodyPr/>
           <a:lstStyle/>
           <a:p>
-            <a:r>
-              <a:rPr lang="en-US" dirty="0"/>
-              <a:t>A. Cladogram of taxa </a:t>
-            </a:r>
-            <a:r>
-              <a:rPr lang="en-US" dirty="0" err="1"/>
-              <a:t>analysed</a:t>
-            </a:r>
-            <a:r>
-              <a:rPr lang="en-US" dirty="0"/>
-              <a:t> for </a:t>
-            </a:r>
-            <a:r>
-              <a:rPr lang="en-US" dirty="0" err="1"/>
-              <a:t>Blattabacterium</a:t>
-            </a:r>
-            <a:r>
-              <a:rPr lang="en-US" dirty="0"/>
-              <a:t> HGT events</a:t>
-            </a:r>
-          </a:p>
-          <a:p>
-            <a:r>
-              <a:rPr lang="en-US" dirty="0"/>
-              <a:t>Nodes show divergence times (Ma) from Beasley-Hall et al (2021: for nodes internal to top 12 taxa) and Evangelista et al (2019: for nodes internal to remaining 6 taxa). One exception is value between P. lata and P. cribrata, which is from Adams et al 2024. </a:t>
-            </a:r>
-          </a:p>
-          <a:p>
-            <a:r>
-              <a:rPr lang="en-US" dirty="0"/>
-              <a:t>Comment 1: Could add numbers of genic vs intergenic to (A)</a:t>
-            </a:r>
+            <a:pPr marL="0" marR="0" lvl="0" indent="0" algn="l" defTabSz="914400" rtl="0" eaLnBrk="1" fontAlgn="auto" latinLnBrk="0" hangingPunct="1">
+              <a:lnSpc>
+                <a:spcPct val="100000"/>
+              </a:lnSpc>
+              <a:spcBef>
+                <a:spcPts val="0"/>
+              </a:spcBef>
+              <a:spcAft>
+                <a:spcPts val="0"/>
+              </a:spcAft>
+              <a:buClrTx/>
+              <a:buSzTx/>
+              <a:buFontTx/>
+              <a:buNone/>
+              <a:tabLst/>
+              <a:defRPr/>
+            </a:pPr>
+            <a:r>
+              <a:rPr lang="en-AU" sz="1200" b="1" kern="1200" dirty="0">
+                <a:solidFill>
+                  <a:schemeClr val="tx1"/>
+                </a:solidFill>
+                <a:effectLst/>
+                <a:latin typeface="+mn-lt"/>
+                <a:ea typeface="+mn-ea"/>
+                <a:cs typeface="+mn-cs"/>
+              </a:rPr>
+              <a:t>Figure 4.3</a:t>
+            </a:r>
+            <a:r>
+              <a:rPr lang="en-AU" sz="1200" kern="1200" dirty="0">
+                <a:solidFill>
+                  <a:schemeClr val="tx1"/>
+                </a:solidFill>
+                <a:effectLst/>
+                <a:latin typeface="+mn-lt"/>
+                <a:ea typeface="+mn-ea"/>
+                <a:cs typeface="+mn-cs"/>
+              </a:rPr>
+              <a:t>. Examples of two HGT insertions used for ‘aging’ analysis. The right panel shows homology of each insertion and its 5 kb flanking regions across species: green denotes HGT inserts, blue flanking regions, with red and blue bands indicating forward and inverted homology (darker shades = higher similarity). The left phylogeny is based on Chapter 3; species lacking the insertion are shown as a dashed line. Red arrows indicate the inferred timing of HGT insertions.</a:t>
+            </a:r>
+            <a:endParaRPr lang="en-GB" sz="1200" kern="1200" dirty="0">
+              <a:solidFill>
+                <a:schemeClr val="tx1"/>
+              </a:solidFill>
+              <a:effectLst/>
+              <a:latin typeface="+mn-lt"/>
+              <a:ea typeface="+mn-ea"/>
+              <a:cs typeface="+mn-cs"/>
+            </a:endParaRPr>
           </a:p>
           <a:p>
             <a:endParaRPr lang="en-US" dirty="0"/>
-          </a:p>
-          <a:p>
-            <a:r>
-              <a:rPr lang="en-US" dirty="0"/>
-              <a:t>B. The plot starts at 50 bp, as this was the minimum. I have a maximum cutoff of 1000 bp (75 of the 41103 markers have been excluded).</a:t>
-            </a:r>
-          </a:p>
-          <a:p>
-            <a:r>
-              <a:rPr lang="en-US" dirty="0"/>
-              <a:t>Comment 1: I’m not sure why there are 2 peaks… I can of course fiddle around with the resolution of this graph and flatten out the 2 peaks (not to be dodgy, but just a more coarse summary of the lengths)</a:t>
-            </a:r>
-          </a:p>
-          <a:p>
-            <a:r>
-              <a:rPr lang="en-US" dirty="0"/>
-              <a:t>Comment 2: I’m hoping to add 2 additional curves to the plot (or as additional plots) – 1 for genic and 1 for intergenic.</a:t>
-            </a:r>
-          </a:p>
-          <a:p>
-            <a:endParaRPr lang="en-US" dirty="0"/>
-          </a:p>
-          <a:p>
-            <a:r>
-              <a:rPr lang="en-US" dirty="0"/>
-              <a:t>C. Placeholder for Leo figure</a:t>
-            </a:r>
           </a:p>
         </p:txBody>
       </p:sp>
@@ -993,7 +970,7 @@
     </p:spTree>
     <p:extLst>
       <p:ext uri="{BB962C8B-B14F-4D97-AF65-F5344CB8AC3E}">
-        <p14:creationId xmlns:p14="http://schemas.microsoft.com/office/powerpoint/2010/main" val="2564932199"/>
+        <p14:creationId xmlns:p14="http://schemas.microsoft.com/office/powerpoint/2010/main" val="578356381"/>
       </p:ext>
     </p:extLst>
   </p:cSld>
@@ -1047,59 +1024,10 @@
           <a:bodyPr/>
           <a:lstStyle/>
           <a:p>
-            <a:pPr marL="0" marR="0" lvl="0" indent="0" algn="l" defTabSz="914400" rtl="0" eaLnBrk="1" fontAlgn="auto" latinLnBrk="0" hangingPunct="1">
-              <a:lnSpc>
-                <a:spcPct val="100000"/>
-              </a:lnSpc>
-              <a:spcBef>
-                <a:spcPts val="0"/>
-              </a:spcBef>
-              <a:spcAft>
-                <a:spcPts val="0"/>
-              </a:spcAft>
-              <a:buClrTx/>
-              <a:buSzTx/>
-              <a:buFontTx/>
-              <a:buNone/>
-              <a:tabLst/>
-              <a:defRPr/>
-            </a:pPr>
-            <a:r>
-              <a:rPr lang="en-AU" sz="1200" b="1" kern="1200" dirty="0">
-                <a:solidFill>
-                  <a:schemeClr val="tx1"/>
-                </a:solidFill>
-                <a:effectLst/>
-                <a:latin typeface="+mn-lt"/>
-                <a:ea typeface="+mn-ea"/>
-                <a:cs typeface="+mn-cs"/>
-              </a:rPr>
-              <a:t>Figure 4.3</a:t>
-            </a:r>
-            <a:r>
-              <a:rPr lang="en-AU" sz="1200" kern="1200" dirty="0">
-                <a:solidFill>
-                  <a:schemeClr val="tx1"/>
-                </a:solidFill>
-                <a:effectLst/>
-                <a:latin typeface="+mn-lt"/>
-                <a:ea typeface="+mn-ea"/>
-                <a:cs typeface="+mn-cs"/>
-              </a:rPr>
-              <a:t>. Examples of two HGT insertions used for ‘aging’ analysis. The right panel shows homology of each insertion and its 5 kb flanking regions across species: green denotes HGT inserts, blue flanking regions, with red and blue bands indicating forward and inverted homology (darker shades = higher similarity). The left phylogeny is based on Chapter 3; species lacking the insertion are shown as a dashed line. Red arrows indicate the inferred timing of HGT insertions.</a:t>
-            </a:r>
-            <a:endParaRPr lang="en-GB" sz="1200" kern="1200" dirty="0">
-              <a:solidFill>
-                <a:schemeClr val="tx1"/>
-              </a:solidFill>
-              <a:effectLst/>
-              <a:latin typeface="+mn-lt"/>
-              <a:ea typeface="+mn-ea"/>
-              <a:cs typeface="+mn-cs"/>
-            </a:endParaRPr>
-          </a:p>
-          <a:p>
-            <a:endParaRPr lang="en-US" dirty="0"/>
+            <a:r>
+              <a:rPr lang="en-US" dirty="0"/>
+              <a:t>Example of a chimeric HGT insertion from P. tryoni tegminifera. The top sequence is divided into seven segments, while the circular map below represents the source genome of Blattabacterium cuenoti (CP142624.1). Numbers below the insertion indicate the corresponding genomic positions, with yellow labels marking specific coordinates.</a:t>
+            </a:r>
           </a:p>
         </p:txBody>
       </p:sp>
@@ -1129,7 +1057,7 @@
     </p:spTree>
     <p:extLst>
       <p:ext uri="{BB962C8B-B14F-4D97-AF65-F5344CB8AC3E}">
-        <p14:creationId xmlns:p14="http://schemas.microsoft.com/office/powerpoint/2010/main" val="578356381"/>
+        <p14:creationId xmlns:p14="http://schemas.microsoft.com/office/powerpoint/2010/main" val="2973060748"/>
       </p:ext>
     </p:extLst>
   </p:cSld>
@@ -1185,27 +1113,45 @@
           <a:p>
             <a:r>
               <a:rPr lang="en-US" dirty="0"/>
-              <a:t>Figure 4.4. Example of a chimeric HGT insertion from P. tryoni tegminifera. The top sequence is divided into seven segments, while the circular map below represents the source genome of </a:t>
+              <a:t>A. Cladogram of taxa </a:t>
             </a:r>
             <a:r>
               <a:rPr lang="en-US" dirty="0" err="1"/>
-              <a:t>Blattabacterium</a:t>
+              <a:t>analysed</a:t>
             </a:r>
             <a:r>
               <a:rPr lang="en-US" dirty="0"/>
-              <a:t> </a:t>
-            </a:r>
-            <a:r>
-              <a:rPr lang="en-US" dirty="0" err="1"/>
-              <a:t>cuenoti</a:t>
-            </a:r>
+              <a:t> for Blattabacterium HGT events</a:t>
+            </a:r>
+          </a:p>
+          <a:p>
             <a:r>
               <a:rPr lang="en-US" dirty="0"/>
-              <a:t> (CP142624.1). </a:t>
-            </a:r>
-            <a:r>
-              <a:rPr lang="en-US"/>
-              <a:t>Numbers below the insertion indicate the corresponding genomic positions, with yellow labels marking specific coordinates.</a:t>
+              <a:t>Nodes show divergence times (Ma) from Beasley-Hall et al (2021: for nodes internal to top 12 taxa) and Evangelista et al (2019: for nodes internal to remaining 6 taxa). One exception is value between P. lata and P. cribrata, which is from Adams et al 2024. </a:t>
+            </a:r>
+          </a:p>
+          <a:p>
+            <a:r>
+              <a:rPr lang="en-US" dirty="0"/>
+              <a:t>Comment 1: Could add numbers of genic vs intergenic to (A)</a:t>
+            </a:r>
+          </a:p>
+          <a:p>
+            <a:endParaRPr lang="en-US" dirty="0"/>
+          </a:p>
+          <a:p>
+            <a:r>
+              <a:rPr lang="en-US" dirty="0"/>
+              <a:t>B. The plot starts at 50 bp, as this was the minimum. I have a maximum cutoff of 1000 bp (75 of the 41103 markers have been excluded).</a:t>
+            </a:r>
+          </a:p>
+          <a:p>
+            <a:endParaRPr lang="en-US" dirty="0"/>
+          </a:p>
+          <a:p>
+            <a:r>
+              <a:rPr lang="en-US" dirty="0"/>
+              <a:t>C. Placeholder for Leo figure</a:t>
             </a:r>
           </a:p>
         </p:txBody>
@@ -1227,7 +1173,7 @@
           <a:p>
             <a:fld id="{AFCB7D11-0DA4-4649-ACEB-1F19D5C36BF9}" type="slidenum">
               <a:rPr lang="en-US" smtClean="0"/>
-              <a:t>9</a:t>
+              <a:t>10</a:t>
             </a:fld>
             <a:endParaRPr lang="en-US"/>
           </a:p>
@@ -1236,7 +1182,217 @@
     </p:spTree>
     <p:extLst>
       <p:ext uri="{BB962C8B-B14F-4D97-AF65-F5344CB8AC3E}">
-        <p14:creationId xmlns:p14="http://schemas.microsoft.com/office/powerpoint/2010/main" val="2973060748"/>
+        <p14:creationId xmlns:p14="http://schemas.microsoft.com/office/powerpoint/2010/main" val="2564932199"/>
+      </p:ext>
+    </p:extLst>
+  </p:cSld>
+  <p:clrMapOvr>
+    <a:masterClrMapping/>
+  </p:clrMapOvr>
+</p:notes>
+</file>
+
+<file path=ppt/notesSlides/notesSlide7.xml><?xml version="1.0" encoding="utf-8"?>
+<p:notes xmlns:a="http://schemas.openxmlformats.org/drawingml/2006/main" xmlns:r="http://schemas.openxmlformats.org/officeDocument/2006/relationships" xmlns:p="http://schemas.openxmlformats.org/presentationml/2006/main">
+  <p:cSld>
+    <p:spTree>
+      <p:nvGrpSpPr>
+        <p:cNvPr id="1" name=""/>
+        <p:cNvGrpSpPr/>
+        <p:nvPr/>
+      </p:nvGrpSpPr>
+      <p:grpSpPr>
+        <a:xfrm>
+          <a:off x="0" y="0"/>
+          <a:ext cx="0" cy="0"/>
+          <a:chOff x="0" y="0"/>
+          <a:chExt cx="0" cy="0"/>
+        </a:xfrm>
+      </p:grpSpPr>
+      <p:sp>
+        <p:nvSpPr>
+          <p:cNvPr id="2" name="Slide Image Placeholder 1"/>
+          <p:cNvSpPr>
+            <a:spLocks noGrp="1" noRot="1" noChangeAspect="1"/>
+          </p:cNvSpPr>
+          <p:nvPr>
+            <p:ph type="sldImg"/>
+          </p:nvPr>
+        </p:nvSpPr>
+        <p:spPr/>
+      </p:sp>
+      <p:sp>
+        <p:nvSpPr>
+          <p:cNvPr id="3" name="Notes Placeholder 2"/>
+          <p:cNvSpPr>
+            <a:spLocks noGrp="1"/>
+          </p:cNvSpPr>
+          <p:nvPr>
+            <p:ph type="body" idx="1"/>
+          </p:nvPr>
+        </p:nvSpPr>
+        <p:spPr/>
+        <p:txBody>
+          <a:bodyPr/>
+          <a:lstStyle/>
+          <a:p>
+            <a:pPr marL="228600" indent="-228600">
+              <a:buAutoNum type="alphaUcPeriod"/>
+            </a:pPr>
+            <a:r>
+              <a:rPr lang="en-US" dirty="0"/>
+              <a:t>P-</a:t>
+            </a:r>
+            <a:r>
+              <a:rPr lang="en-US" dirty="0" err="1"/>
+              <a:t>tryoni</a:t>
+            </a:r>
+            <a:r>
+              <a:rPr lang="en-US" dirty="0"/>
+              <a:t>-</a:t>
+            </a:r>
+            <a:r>
+              <a:rPr lang="en-US" dirty="0" err="1"/>
+              <a:t>tryoni</a:t>
+            </a:r>
+            <a:r>
+              <a:rPr lang="en-US" dirty="0"/>
+              <a:t>-</a:t>
+            </a:r>
+            <a:r>
+              <a:rPr lang="en-US" dirty="0" err="1"/>
+              <a:t>Eungella_ageing</a:t>
+            </a:r>
+            <a:r>
+              <a:rPr lang="en-US" dirty="0"/>
+              <a:t>-plot. BLAST %ID against Blattabacterium database - BLAST %ID against insert database </a:t>
+            </a:r>
+          </a:p>
+          <a:p>
+            <a:r>
+              <a:rPr lang="en-US" dirty="0"/>
+              <a:t>B. Examples of one HGT insertions used for ‘aging’ analysis. The right panel shows homology of each insertion and its 5 kb flanking regions across species: green denotes HGT inserts, blue flanking regions, with red and blue bands indicating forward and inverted homology (darker shades = higher similarity). The left phylogeny is based on Chapter 3; species lacking the insertion are shown as a dashed line. Red arrows indicate the inferred timing of HGT insertions.</a:t>
+            </a:r>
+          </a:p>
+          <a:p>
+            <a:endParaRPr lang="en-US" dirty="0"/>
+          </a:p>
+        </p:txBody>
+      </p:sp>
+      <p:sp>
+        <p:nvSpPr>
+          <p:cNvPr id="4" name="Slide Number Placeholder 3"/>
+          <p:cNvSpPr>
+            <a:spLocks noGrp="1"/>
+          </p:cNvSpPr>
+          <p:nvPr>
+            <p:ph type="sldNum" sz="quarter" idx="5"/>
+          </p:nvPr>
+        </p:nvSpPr>
+        <p:spPr/>
+        <p:txBody>
+          <a:bodyPr/>
+          <a:lstStyle/>
+          <a:p>
+            <a:fld id="{AFCB7D11-0DA4-4649-ACEB-1F19D5C36BF9}" type="slidenum">
+              <a:rPr lang="en-US" smtClean="0"/>
+              <a:t>11</a:t>
+            </a:fld>
+            <a:endParaRPr lang="en-US"/>
+          </a:p>
+        </p:txBody>
+      </p:sp>
+    </p:spTree>
+    <p:extLst>
+      <p:ext uri="{BB962C8B-B14F-4D97-AF65-F5344CB8AC3E}">
+        <p14:creationId xmlns:p14="http://schemas.microsoft.com/office/powerpoint/2010/main" val="1427805513"/>
+      </p:ext>
+    </p:extLst>
+  </p:cSld>
+  <p:clrMapOvr>
+    <a:masterClrMapping/>
+  </p:clrMapOvr>
+</p:notes>
+</file>
+
+<file path=ppt/notesSlides/notesSlide8.xml><?xml version="1.0" encoding="utf-8"?>
+<p:notes xmlns:a="http://schemas.openxmlformats.org/drawingml/2006/main" xmlns:r="http://schemas.openxmlformats.org/officeDocument/2006/relationships" xmlns:p="http://schemas.openxmlformats.org/presentationml/2006/main">
+  <p:cSld>
+    <p:spTree>
+      <p:nvGrpSpPr>
+        <p:cNvPr id="1" name=""/>
+        <p:cNvGrpSpPr/>
+        <p:nvPr/>
+      </p:nvGrpSpPr>
+      <p:grpSpPr>
+        <a:xfrm>
+          <a:off x="0" y="0"/>
+          <a:ext cx="0" cy="0"/>
+          <a:chOff x="0" y="0"/>
+          <a:chExt cx="0" cy="0"/>
+        </a:xfrm>
+      </p:grpSpPr>
+      <p:sp>
+        <p:nvSpPr>
+          <p:cNvPr id="2" name="Slide Image Placeholder 1"/>
+          <p:cNvSpPr>
+            <a:spLocks noGrp="1" noRot="1" noChangeAspect="1"/>
+          </p:cNvSpPr>
+          <p:nvPr>
+            <p:ph type="sldImg"/>
+          </p:nvPr>
+        </p:nvSpPr>
+        <p:spPr/>
+      </p:sp>
+      <p:sp>
+        <p:nvSpPr>
+          <p:cNvPr id="3" name="Notes Placeholder 2"/>
+          <p:cNvSpPr>
+            <a:spLocks noGrp="1"/>
+          </p:cNvSpPr>
+          <p:nvPr>
+            <p:ph type="body" idx="1"/>
+          </p:nvPr>
+        </p:nvSpPr>
+        <p:spPr/>
+        <p:txBody>
+          <a:bodyPr/>
+          <a:lstStyle/>
+          <a:p>
+            <a:r>
+              <a:rPr lang="en-US" dirty="0"/>
+              <a:t>Example of a chimeric HGT insertion from P. tryoni tegminifera. The top sequence is divided into seven segments, while the circular map below represents the source genome of Blattabacterium cuenoti (CP142624.1). Numbers below the insertion indicate the corresponding genomic positions, with yellow labels marking specific coordinates.</a:t>
+            </a:r>
+          </a:p>
+        </p:txBody>
+      </p:sp>
+      <p:sp>
+        <p:nvSpPr>
+          <p:cNvPr id="4" name="Slide Number Placeholder 3"/>
+          <p:cNvSpPr>
+            <a:spLocks noGrp="1"/>
+          </p:cNvSpPr>
+          <p:nvPr>
+            <p:ph type="sldNum" sz="quarter" idx="5"/>
+          </p:nvPr>
+        </p:nvSpPr>
+        <p:spPr/>
+        <p:txBody>
+          <a:bodyPr/>
+          <a:lstStyle/>
+          <a:p>
+            <a:fld id="{AFCB7D11-0DA4-4649-ACEB-1F19D5C36BF9}" type="slidenum">
+              <a:rPr lang="en-US" smtClean="0"/>
+              <a:t>12</a:t>
+            </a:fld>
+            <a:endParaRPr lang="en-US"/>
+          </a:p>
+        </p:txBody>
+      </p:sp>
+    </p:spTree>
+    <p:extLst>
+      <p:ext uri="{BB962C8B-B14F-4D97-AF65-F5344CB8AC3E}">
+        <p14:creationId xmlns:p14="http://schemas.microsoft.com/office/powerpoint/2010/main" val="1015573314"/>
       </p:ext>
     </p:extLst>
   </p:cSld>
@@ -1393,7 +1549,7 @@
           <a:p>
             <a:fld id="{C2B98897-90D8-9D4D-95EE-51EF37A9743C}" type="datetimeFigureOut">
               <a:rPr lang="en-US" smtClean="0"/>
-              <a:t>10/28/25</a:t>
+              <a:t>10/29/25</a:t>
             </a:fld>
             <a:endParaRPr lang="en-US"/>
           </a:p>
@@ -1591,7 +1747,7 @@
           <a:p>
             <a:fld id="{C2B98897-90D8-9D4D-95EE-51EF37A9743C}" type="datetimeFigureOut">
               <a:rPr lang="en-US" smtClean="0"/>
-              <a:t>10/28/25</a:t>
+              <a:t>10/29/25</a:t>
             </a:fld>
             <a:endParaRPr lang="en-US"/>
           </a:p>
@@ -1799,7 +1955,7 @@
           <a:p>
             <a:fld id="{C2B98897-90D8-9D4D-95EE-51EF37A9743C}" type="datetimeFigureOut">
               <a:rPr lang="en-US" smtClean="0"/>
-              <a:t>10/28/25</a:t>
+              <a:t>10/29/25</a:t>
             </a:fld>
             <a:endParaRPr lang="en-US"/>
           </a:p>
@@ -1997,7 +2153,7 @@
           <a:p>
             <a:fld id="{C2B98897-90D8-9D4D-95EE-51EF37A9743C}" type="datetimeFigureOut">
               <a:rPr lang="en-US" smtClean="0"/>
-              <a:t>10/28/25</a:t>
+              <a:t>10/29/25</a:t>
             </a:fld>
             <a:endParaRPr lang="en-US"/>
           </a:p>
@@ -2272,7 +2428,7 @@
           <a:p>
             <a:fld id="{C2B98897-90D8-9D4D-95EE-51EF37A9743C}" type="datetimeFigureOut">
               <a:rPr lang="en-US" smtClean="0"/>
-              <a:t>10/28/25</a:t>
+              <a:t>10/29/25</a:t>
             </a:fld>
             <a:endParaRPr lang="en-US"/>
           </a:p>
@@ -2537,7 +2693,7 @@
           <a:p>
             <a:fld id="{C2B98897-90D8-9D4D-95EE-51EF37A9743C}" type="datetimeFigureOut">
               <a:rPr lang="en-US" smtClean="0"/>
-              <a:t>10/28/25</a:t>
+              <a:t>10/29/25</a:t>
             </a:fld>
             <a:endParaRPr lang="en-US"/>
           </a:p>
@@ -2949,7 +3105,7 @@
           <a:p>
             <a:fld id="{C2B98897-90D8-9D4D-95EE-51EF37A9743C}" type="datetimeFigureOut">
               <a:rPr lang="en-US" smtClean="0"/>
-              <a:t>10/28/25</a:t>
+              <a:t>10/29/25</a:t>
             </a:fld>
             <a:endParaRPr lang="en-US"/>
           </a:p>
@@ -3090,7 +3246,7 @@
           <a:p>
             <a:fld id="{C2B98897-90D8-9D4D-95EE-51EF37A9743C}" type="datetimeFigureOut">
               <a:rPr lang="en-US" smtClean="0"/>
-              <a:t>10/28/25</a:t>
+              <a:t>10/29/25</a:t>
             </a:fld>
             <a:endParaRPr lang="en-US"/>
           </a:p>
@@ -3203,7 +3359,7 @@
           <a:p>
             <a:fld id="{C2B98897-90D8-9D4D-95EE-51EF37A9743C}" type="datetimeFigureOut">
               <a:rPr lang="en-US" smtClean="0"/>
-              <a:t>10/28/25</a:t>
+              <a:t>10/29/25</a:t>
             </a:fld>
             <a:endParaRPr lang="en-US"/>
           </a:p>
@@ -3514,7 +3670,7 @@
           <a:p>
             <a:fld id="{C2B98897-90D8-9D4D-95EE-51EF37A9743C}" type="datetimeFigureOut">
               <a:rPr lang="en-US" smtClean="0"/>
-              <a:t>10/28/25</a:t>
+              <a:t>10/29/25</a:t>
             </a:fld>
             <a:endParaRPr lang="en-US"/>
           </a:p>
@@ -3802,7 +3958,7 @@
           <a:p>
             <a:fld id="{C2B98897-90D8-9D4D-95EE-51EF37A9743C}" type="datetimeFigureOut">
               <a:rPr lang="en-US" smtClean="0"/>
-              <a:t>10/28/25</a:t>
+              <a:t>10/29/25</a:t>
             </a:fld>
             <a:endParaRPr lang="en-US"/>
           </a:p>
@@ -4043,7 +4199,7 @@
           <a:p>
             <a:fld id="{C2B98897-90D8-9D4D-95EE-51EF37A9743C}" type="datetimeFigureOut">
               <a:rPr lang="en-US" smtClean="0"/>
-              <a:t>10/28/25</a:t>
+              <a:t>10/29/25</a:t>
             </a:fld>
             <a:endParaRPr lang="en-US"/>
           </a:p>
@@ -8051,7 +8207,7 @@
               <a:t> for </a:t>
             </a:r>
             <a:r>
-              <a:rPr lang="en-US" sz="2400" b="1" i="1" dirty="0" err="1">
+              <a:rPr lang="en-US" sz="2400" b="1" i="1" dirty="0">
                 <a:latin typeface="Arial" panose="020B0604020202020204" pitchFamily="34" charset="0"/>
                 <a:cs typeface="Arial" panose="020B0604020202020204" pitchFamily="34" charset="0"/>
               </a:rPr>
@@ -8920,23 +9076,7 @@
                   <a:srgbClr val="FF0000"/>
                 </a:solidFill>
               </a:rPr>
-              <a:t>right? When I did an audit in early 2025 I found none were </a:t>
-            </a:r>
-            <a:r>
-              <a:rPr lang="en-US" sz="1200" dirty="0" err="1">
-                <a:solidFill>
-                  <a:srgbClr val="FF0000"/>
-                </a:solidFill>
-              </a:rPr>
-              <a:t>Blattabacterium</a:t>
-            </a:r>
-            <a:r>
-              <a:rPr lang="en-US" sz="1200" dirty="0">
-                <a:solidFill>
-                  <a:srgbClr val="FF0000"/>
-                </a:solidFill>
-              </a:rPr>
-              <a:t>?</a:t>
+              <a:t>right? When I did an audit in early 2025 I found none were Blattabacterium?</a:t>
             </a:r>
           </a:p>
         </p:txBody>
@@ -8971,12 +9111,42 @@
           <a:chExt cx="0" cy="0"/>
         </a:xfrm>
       </p:grpSpPr>
-      <p:sp>
-        <p:nvSpPr>
-          <p:cNvPr id="4" name="TextBox 3">
-            <a:extLst>
-              <a:ext uri="{FF2B5EF4-FFF2-40B4-BE49-F238E27FC236}">
-                <a16:creationId xmlns:a16="http://schemas.microsoft.com/office/drawing/2014/main" id="{4CBCCAAD-C40A-0540-A342-CC95BED36479}"/>
+      <p:pic>
+        <p:nvPicPr>
+          <p:cNvPr id="2" name="Picture 1">
+            <a:extLst>
+              <a:ext uri="{FF2B5EF4-FFF2-40B4-BE49-F238E27FC236}">
+                <a16:creationId xmlns:a16="http://schemas.microsoft.com/office/drawing/2014/main" id="{A45A0E29-9F21-FC4B-A4F5-B53517A41FC2}"/>
+              </a:ext>
+            </a:extLst>
+          </p:cNvPr>
+          <p:cNvPicPr>
+            <a:picLocks noChangeAspect="1"/>
+          </p:cNvPicPr>
+          <p:nvPr/>
+        </p:nvPicPr>
+        <p:blipFill>
+          <a:blip r:embed="rId3"/>
+          <a:stretch>
+            <a:fillRect/>
+          </a:stretch>
+        </p:blipFill>
+        <p:spPr>
+          <a:xfrm>
+            <a:off x="75050" y="454968"/>
+            <a:ext cx="6561506" cy="4396430"/>
+          </a:xfrm>
+          <a:prstGeom prst="rect">
+            <a:avLst/>
+          </a:prstGeom>
+        </p:spPr>
+      </p:pic>
+      <p:sp>
+        <p:nvSpPr>
+          <p:cNvPr id="5" name="TextBox 4">
+            <a:extLst>
+              <a:ext uri="{FF2B5EF4-FFF2-40B4-BE49-F238E27FC236}">
+                <a16:creationId xmlns:a16="http://schemas.microsoft.com/office/drawing/2014/main" id="{4F756E17-FE9E-4DC6-F3CF-AABBBF0B49DD}"/>
               </a:ext>
             </a:extLst>
           </p:cNvPr>
@@ -8985,8 +9155,72 @@
         </p:nvSpPr>
         <p:spPr>
           <a:xfrm>
-            <a:off x="152327" y="-28505"/>
-            <a:ext cx="943528" cy="369332"/>
+            <a:off x="7856065" y="3519340"/>
+            <a:ext cx="3343468" cy="830997"/>
+          </a:xfrm>
+          <a:prstGeom prst="rect">
+            <a:avLst/>
+          </a:prstGeom>
+          <a:noFill/>
+        </p:spPr>
+        <p:txBody>
+          <a:bodyPr wrap="square" rtlCol="0">
+            <a:spAutoFit/>
+          </a:bodyPr>
+          <a:lstStyle/>
+          <a:p>
+            <a:pPr algn="ctr"/>
+            <a:r>
+              <a:rPr lang="en-US" sz="1600" b="1" dirty="0">
+                <a:solidFill>
+                  <a:srgbClr val="FF0000"/>
+                </a:solidFill>
+              </a:rPr>
+              <a:t>C. </a:t>
+            </a:r>
+            <a:r>
+              <a:rPr lang="en-US" sz="1600" dirty="0">
+                <a:solidFill>
+                  <a:srgbClr val="FF0000"/>
+                </a:solidFill>
+              </a:rPr>
+              <a:t>Placeholder: depiction of the origin of the insert around the </a:t>
+            </a:r>
+            <a:r>
+              <a:rPr lang="en-US" sz="1600" dirty="0" err="1">
+                <a:solidFill>
+                  <a:srgbClr val="FF0000"/>
+                </a:solidFill>
+              </a:rPr>
+              <a:t>Blatta</a:t>
+            </a:r>
+            <a:r>
+              <a:rPr lang="en-US" sz="1600" dirty="0">
+                <a:solidFill>
+                  <a:srgbClr val="FF0000"/>
+                </a:solidFill>
+              </a:rPr>
+              <a:t> genome (waiting on Leo)</a:t>
+            </a:r>
+          </a:p>
+        </p:txBody>
+      </p:sp>
+      <p:sp>
+        <p:nvSpPr>
+          <p:cNvPr id="7" name="TextBox 6">
+            <a:extLst>
+              <a:ext uri="{FF2B5EF4-FFF2-40B4-BE49-F238E27FC236}">
+                <a16:creationId xmlns:a16="http://schemas.microsoft.com/office/drawing/2014/main" id="{1C0E847B-8FC5-0867-7196-259B77611FF8}"/>
+              </a:ext>
+            </a:extLst>
+          </p:cNvPr>
+          <p:cNvSpPr txBox="1"/>
+          <p:nvPr/>
+        </p:nvSpPr>
+        <p:spPr>
+          <a:xfrm>
+            <a:off x="215683" y="425302"/>
+            <a:ext cx="324128" cy="369332"/>
           </a:xfrm>
           <a:prstGeom prst="rect">
             <a:avLst/>
@@ -9001,17 +9235,48 @@
           <a:p>
             <a:r>
               <a:rPr lang="en-US" b="1" dirty="0"/>
-              <a:t>Figure 2</a:t>
-            </a:r>
-          </a:p>
-        </p:txBody>
-      </p:sp>
-      <p:sp>
-        <p:nvSpPr>
-          <p:cNvPr id="5" name="TextBox 4">
-            <a:extLst>
-              <a:ext uri="{FF2B5EF4-FFF2-40B4-BE49-F238E27FC236}">
-                <a16:creationId xmlns:a16="http://schemas.microsoft.com/office/drawing/2014/main" id="{C10DAFDE-3EB3-4D4D-8B16-A4102844234F}"/>
+              <a:t>A</a:t>
+            </a:r>
+          </a:p>
+        </p:txBody>
+      </p:sp>
+      <p:pic>
+        <p:nvPicPr>
+          <p:cNvPr id="13" name="Picture 12">
+            <a:extLst>
+              <a:ext uri="{FF2B5EF4-FFF2-40B4-BE49-F238E27FC236}">
+                <a16:creationId xmlns:a16="http://schemas.microsoft.com/office/drawing/2014/main" id="{DC883A01-AA48-044E-76DC-460544A87194}"/>
+              </a:ext>
+            </a:extLst>
+          </p:cNvPr>
+          <p:cNvPicPr>
+            <a:picLocks noChangeAspect="1"/>
+          </p:cNvPicPr>
+          <p:nvPr/>
+        </p:nvPicPr>
+        <p:blipFill>
+          <a:blip r:embed="rId4"/>
+          <a:srcRect t="5172"/>
+          <a:stretch>
+            <a:fillRect/>
+          </a:stretch>
+        </p:blipFill>
+        <p:spPr>
+          <a:xfrm>
+            <a:off x="7048374" y="496730"/>
+            <a:ext cx="5104657" cy="2587255"/>
+          </a:xfrm>
+          <a:prstGeom prst="rect">
+            <a:avLst/>
+          </a:prstGeom>
+        </p:spPr>
+      </p:pic>
+      <p:sp>
+        <p:nvSpPr>
+          <p:cNvPr id="14" name="TextBox 13">
+            <a:extLst>
+              <a:ext uri="{FF2B5EF4-FFF2-40B4-BE49-F238E27FC236}">
+                <a16:creationId xmlns:a16="http://schemas.microsoft.com/office/drawing/2014/main" id="{2C6B5942-B39C-46A8-0714-63EF48E22894}"/>
               </a:ext>
             </a:extLst>
           </p:cNvPr>
@@ -9020,8 +9285,8 @@
         </p:nvSpPr>
         <p:spPr>
           <a:xfrm>
-            <a:off x="1544595" y="2211859"/>
-            <a:ext cx="4593309" cy="1200329"/>
+            <a:off x="6720534" y="425302"/>
+            <a:ext cx="314510" cy="369332"/>
           </a:xfrm>
           <a:prstGeom prst="rect">
             <a:avLst/>
@@ -9035,36 +9300,537 @@
           <a:lstStyle/>
           <a:p>
             <a:r>
-              <a:rPr lang="en-US" dirty="0" err="1"/>
-              <a:t>Zhuzhi</a:t>
-            </a:r>
-            <a:r>
-              <a:rPr lang="en-US" dirty="0"/>
-              <a:t> figure.</a:t>
-            </a:r>
-          </a:p>
-          <a:p>
-            <a:endParaRPr lang="en-US" dirty="0"/>
-          </a:p>
-          <a:p>
-            <a:r>
-              <a:rPr lang="en-US" dirty="0"/>
-              <a:t>Also maybe a couple of figure about old inserts</a:t>
-            </a:r>
-          </a:p>
-          <a:p>
-            <a:r>
-              <a:rPr lang="en-US" dirty="0"/>
-              <a:t>- An example from my one, and </a:t>
-            </a:r>
-            <a:r>
-              <a:rPr lang="en-US" dirty="0" err="1"/>
-              <a:t>Zhuzhi’s</a:t>
-            </a:r>
-            <a:r>
-              <a:rPr lang="en-US" dirty="0"/>
-              <a:t> one.</a:t>
-            </a:r>
+              <a:rPr lang="en-US" b="1" dirty="0"/>
+              <a:t>B</a:t>
+            </a:r>
+          </a:p>
+        </p:txBody>
+      </p:sp>
+    </p:spTree>
+    <p:extLst>
+      <p:ext uri="{BB962C8B-B14F-4D97-AF65-F5344CB8AC3E}">
+        <p14:creationId xmlns:p14="http://schemas.microsoft.com/office/powerpoint/2010/main" val="2560380269"/>
+      </p:ext>
+    </p:extLst>
+  </p:cSld>
+  <p:clrMapOvr>
+    <a:masterClrMapping/>
+  </p:clrMapOvr>
+</p:sld>
+</file>
+
+<file path=ppt/slides/slide11.xml><?xml version="1.0" encoding="utf-8"?>
+<p:sld xmlns:a="http://schemas.openxmlformats.org/drawingml/2006/main" xmlns:r="http://schemas.openxmlformats.org/officeDocument/2006/relationships" xmlns:p="http://schemas.openxmlformats.org/presentationml/2006/main">
+  <p:cSld>
+    <p:spTree>
+      <p:nvGrpSpPr>
+        <p:cNvPr id="1" name=""/>
+        <p:cNvGrpSpPr/>
+        <p:nvPr/>
+      </p:nvGrpSpPr>
+      <p:grpSpPr>
+        <a:xfrm>
+          <a:off x="0" y="0"/>
+          <a:ext cx="0" cy="0"/>
+          <a:chOff x="0" y="0"/>
+          <a:chExt cx="0" cy="0"/>
+        </a:xfrm>
+      </p:grpSpPr>
+      <p:sp>
+        <p:nvSpPr>
+          <p:cNvPr id="4" name="TextBox 3">
+            <a:extLst>
+              <a:ext uri="{FF2B5EF4-FFF2-40B4-BE49-F238E27FC236}">
+                <a16:creationId xmlns:a16="http://schemas.microsoft.com/office/drawing/2014/main" id="{4CBCCAAD-C40A-0540-A342-CC95BED36479}"/>
+              </a:ext>
+            </a:extLst>
+          </p:cNvPr>
+          <p:cNvSpPr txBox="1"/>
+          <p:nvPr/>
+        </p:nvSpPr>
+        <p:spPr>
+          <a:xfrm>
+            <a:off x="152327" y="-28505"/>
+            <a:ext cx="943528" cy="369332"/>
+          </a:xfrm>
+          <a:prstGeom prst="rect">
+            <a:avLst/>
+          </a:prstGeom>
+          <a:noFill/>
+        </p:spPr>
+        <p:txBody>
+          <a:bodyPr wrap="none" rtlCol="0">
+            <a:spAutoFit/>
+          </a:bodyPr>
+          <a:lstStyle/>
+          <a:p>
+            <a:r>
+              <a:rPr lang="en-US" b="1" dirty="0"/>
+              <a:t>Figure 2</a:t>
+            </a:r>
+          </a:p>
+        </p:txBody>
+      </p:sp>
+      <p:pic>
+        <p:nvPicPr>
+          <p:cNvPr id="6" name="Picture 5">
+            <a:extLst>
+              <a:ext uri="{FF2B5EF4-FFF2-40B4-BE49-F238E27FC236}">
+                <a16:creationId xmlns:a16="http://schemas.microsoft.com/office/drawing/2014/main" id="{D2107C2B-7AD9-0940-814D-542810A3F058}"/>
+              </a:ext>
+            </a:extLst>
+          </p:cNvPr>
+          <p:cNvPicPr>
+            <a:picLocks noChangeAspect="1"/>
+          </p:cNvPicPr>
+          <p:nvPr/>
+        </p:nvPicPr>
+        <p:blipFill rotWithShape="1">
+          <a:blip r:embed="rId3"/>
+          <a:srcRect t="52525"/>
+          <a:stretch/>
+        </p:blipFill>
+        <p:spPr>
+          <a:xfrm>
+            <a:off x="6369518" y="1648788"/>
+            <a:ext cx="5689283" cy="3981303"/>
+          </a:xfrm>
+          <a:prstGeom prst="rect">
+            <a:avLst/>
+          </a:prstGeom>
+        </p:spPr>
+      </p:pic>
+      <p:pic>
+        <p:nvPicPr>
+          <p:cNvPr id="7" name="Picture 6">
+            <a:extLst>
+              <a:ext uri="{FF2B5EF4-FFF2-40B4-BE49-F238E27FC236}">
+                <a16:creationId xmlns:a16="http://schemas.microsoft.com/office/drawing/2014/main" id="{4D1CA6F0-055A-C240-A4FC-6BEFEB8FFA56}"/>
+              </a:ext>
+            </a:extLst>
+          </p:cNvPr>
+          <p:cNvPicPr>
+            <a:picLocks noChangeAspect="1"/>
+          </p:cNvPicPr>
+          <p:nvPr/>
+        </p:nvPicPr>
+        <p:blipFill rotWithShape="1">
+          <a:blip r:embed="rId4"/>
+          <a:srcRect l="2701" t="7745" r="2136" b="6008"/>
+          <a:stretch/>
+        </p:blipFill>
+        <p:spPr>
+          <a:xfrm>
+            <a:off x="936970" y="1852864"/>
+            <a:ext cx="5423723" cy="3433730"/>
+          </a:xfrm>
+          <a:prstGeom prst="rect">
+            <a:avLst/>
+          </a:prstGeom>
+        </p:spPr>
+      </p:pic>
+      <p:sp>
+        <p:nvSpPr>
+          <p:cNvPr id="2" name="TextBox 1">
+            <a:extLst>
+              <a:ext uri="{FF2B5EF4-FFF2-40B4-BE49-F238E27FC236}">
+                <a16:creationId xmlns:a16="http://schemas.microsoft.com/office/drawing/2014/main" id="{633D4B2A-37ED-CE4F-938D-1864D4E6B025}"/>
+              </a:ext>
+            </a:extLst>
+          </p:cNvPr>
+          <p:cNvSpPr txBox="1"/>
+          <p:nvPr/>
+        </p:nvSpPr>
+        <p:spPr>
+          <a:xfrm>
+            <a:off x="2094074" y="4445366"/>
+            <a:ext cx="1241562" cy="430887"/>
+          </a:xfrm>
+          <a:prstGeom prst="rect">
+            <a:avLst/>
+          </a:prstGeom>
+          <a:noFill/>
+        </p:spPr>
+        <p:txBody>
+          <a:bodyPr wrap="square" rtlCol="0">
+            <a:spAutoFit/>
+          </a:bodyPr>
+          <a:lstStyle/>
+          <a:p>
+            <a:r>
+              <a:rPr lang="en-US" sz="1100" dirty="0"/>
+              <a:t>Putative ancestral inserts</a:t>
+            </a:r>
+          </a:p>
+        </p:txBody>
+      </p:sp>
+      <p:sp>
+        <p:nvSpPr>
+          <p:cNvPr id="8" name="TextBox 7">
+            <a:extLst>
+              <a:ext uri="{FF2B5EF4-FFF2-40B4-BE49-F238E27FC236}">
+                <a16:creationId xmlns:a16="http://schemas.microsoft.com/office/drawing/2014/main" id="{C1A254C8-E221-074A-8EC7-674BF6886A40}"/>
+              </a:ext>
+            </a:extLst>
+          </p:cNvPr>
+          <p:cNvSpPr txBox="1"/>
+          <p:nvPr/>
+        </p:nvSpPr>
+        <p:spPr>
+          <a:xfrm>
+            <a:off x="3862937" y="2027575"/>
+            <a:ext cx="1528056" cy="430887"/>
+          </a:xfrm>
+          <a:prstGeom prst="rect">
+            <a:avLst/>
+          </a:prstGeom>
+          <a:noFill/>
+        </p:spPr>
+        <p:txBody>
+          <a:bodyPr wrap="square" rtlCol="0">
+            <a:spAutoFit/>
+          </a:bodyPr>
+          <a:lstStyle/>
+          <a:p>
+            <a:pPr algn="r"/>
+            <a:r>
+              <a:rPr lang="en-US" sz="1100" dirty="0"/>
+              <a:t>Putative contemporary inserts</a:t>
+            </a:r>
+          </a:p>
+        </p:txBody>
+      </p:sp>
+      <p:sp>
+        <p:nvSpPr>
+          <p:cNvPr id="9" name="TextBox 8">
+            <a:extLst>
+              <a:ext uri="{FF2B5EF4-FFF2-40B4-BE49-F238E27FC236}">
+                <a16:creationId xmlns:a16="http://schemas.microsoft.com/office/drawing/2014/main" id="{A1AB082A-F420-0C48-91D5-4F7BF95C306D}"/>
+              </a:ext>
+            </a:extLst>
+          </p:cNvPr>
+          <p:cNvSpPr txBox="1"/>
+          <p:nvPr/>
+        </p:nvSpPr>
+        <p:spPr>
+          <a:xfrm>
+            <a:off x="4082441" y="3736051"/>
+            <a:ext cx="1281120" cy="261610"/>
+          </a:xfrm>
+          <a:prstGeom prst="rect">
+            <a:avLst/>
+          </a:prstGeom>
+          <a:noFill/>
+        </p:spPr>
+        <p:txBody>
+          <a:bodyPr wrap="none" rtlCol="0">
+            <a:spAutoFit/>
+          </a:bodyPr>
+          <a:lstStyle/>
+          <a:p>
+            <a:r>
+              <a:rPr lang="en-US" sz="1100" dirty="0"/>
+              <a:t>Unable to infer age</a:t>
+            </a:r>
+          </a:p>
+        </p:txBody>
+      </p:sp>
+      <p:sp>
+        <p:nvSpPr>
+          <p:cNvPr id="3" name="TextBox 2">
+            <a:extLst>
+              <a:ext uri="{FF2B5EF4-FFF2-40B4-BE49-F238E27FC236}">
+                <a16:creationId xmlns:a16="http://schemas.microsoft.com/office/drawing/2014/main" id="{56561D6C-B0AC-0E48-A749-34E5EC08CA93}"/>
+              </a:ext>
+            </a:extLst>
+          </p:cNvPr>
+          <p:cNvSpPr txBox="1"/>
+          <p:nvPr/>
+        </p:nvSpPr>
+        <p:spPr>
+          <a:xfrm>
+            <a:off x="3177302" y="5230862"/>
+            <a:ext cx="1064779" cy="307777"/>
+          </a:xfrm>
+          <a:prstGeom prst="rect">
+            <a:avLst/>
+          </a:prstGeom>
+          <a:noFill/>
+        </p:spPr>
+        <p:txBody>
+          <a:bodyPr wrap="none" rtlCol="0">
+            <a:spAutoFit/>
+          </a:bodyPr>
+          <a:lstStyle/>
+          <a:p>
+            <a:r>
+              <a:rPr lang="en-US" sz="1400" dirty="0"/>
+              <a:t>Insert count</a:t>
+            </a:r>
+          </a:p>
+        </p:txBody>
+      </p:sp>
+      <p:sp>
+        <p:nvSpPr>
+          <p:cNvPr id="10" name="TextBox 9">
+            <a:extLst>
+              <a:ext uri="{FF2B5EF4-FFF2-40B4-BE49-F238E27FC236}">
+                <a16:creationId xmlns:a16="http://schemas.microsoft.com/office/drawing/2014/main" id="{90AA9167-B2F4-DB40-8978-942B5407BF84}"/>
+              </a:ext>
+            </a:extLst>
+          </p:cNvPr>
+          <p:cNvSpPr txBox="1"/>
+          <p:nvPr/>
+        </p:nvSpPr>
+        <p:spPr>
+          <a:xfrm rot="16200000">
+            <a:off x="-308369" y="3261666"/>
+            <a:ext cx="2290755" cy="307777"/>
+          </a:xfrm>
+          <a:prstGeom prst="rect">
+            <a:avLst/>
+          </a:prstGeom>
+          <a:noFill/>
+        </p:spPr>
+        <p:txBody>
+          <a:bodyPr wrap="none" rtlCol="0">
+            <a:spAutoFit/>
+          </a:bodyPr>
+          <a:lstStyle/>
+          <a:p>
+            <a:r>
+              <a:rPr lang="en-US" sz="1400" dirty="0"/>
+              <a:t>BLAST identity (%) difference</a:t>
+            </a:r>
+          </a:p>
+        </p:txBody>
+      </p:sp>
+      <p:sp>
+        <p:nvSpPr>
+          <p:cNvPr id="11" name="TextBox 10">
+            <a:extLst>
+              <a:ext uri="{FF2B5EF4-FFF2-40B4-BE49-F238E27FC236}">
+                <a16:creationId xmlns:a16="http://schemas.microsoft.com/office/drawing/2014/main" id="{FDFFE04B-D070-864B-B8B8-CEADF928B4A8}"/>
+              </a:ext>
+            </a:extLst>
+          </p:cNvPr>
+          <p:cNvSpPr txBox="1"/>
+          <p:nvPr/>
+        </p:nvSpPr>
+        <p:spPr>
+          <a:xfrm>
+            <a:off x="563825" y="1753280"/>
+            <a:ext cx="324128" cy="369332"/>
+          </a:xfrm>
+          <a:prstGeom prst="rect">
+            <a:avLst/>
+          </a:prstGeom>
+          <a:noFill/>
+        </p:spPr>
+        <p:txBody>
+          <a:bodyPr wrap="none" rtlCol="0">
+            <a:spAutoFit/>
+          </a:bodyPr>
+          <a:lstStyle/>
+          <a:p>
+            <a:r>
+              <a:rPr lang="en-US" b="1" dirty="0"/>
+              <a:t>A</a:t>
+            </a:r>
+          </a:p>
+        </p:txBody>
+      </p:sp>
+      <p:sp>
+        <p:nvSpPr>
+          <p:cNvPr id="12" name="TextBox 11">
+            <a:extLst>
+              <a:ext uri="{FF2B5EF4-FFF2-40B4-BE49-F238E27FC236}">
+                <a16:creationId xmlns:a16="http://schemas.microsoft.com/office/drawing/2014/main" id="{276F2C94-E046-8F49-A92D-49719149D358}"/>
+              </a:ext>
+            </a:extLst>
+          </p:cNvPr>
+          <p:cNvSpPr txBox="1"/>
+          <p:nvPr/>
+        </p:nvSpPr>
+        <p:spPr>
+          <a:xfrm>
+            <a:off x="6360693" y="1753280"/>
+            <a:ext cx="314510" cy="369332"/>
+          </a:xfrm>
+          <a:prstGeom prst="rect">
+            <a:avLst/>
+          </a:prstGeom>
+          <a:noFill/>
+        </p:spPr>
+        <p:txBody>
+          <a:bodyPr wrap="none" rtlCol="0">
+            <a:spAutoFit/>
+          </a:bodyPr>
+          <a:lstStyle/>
+          <a:p>
+            <a:r>
+              <a:rPr lang="en-US" b="1" dirty="0"/>
+              <a:t>B</a:t>
+            </a:r>
+          </a:p>
+        </p:txBody>
+      </p:sp>
+      <p:sp>
+        <p:nvSpPr>
+          <p:cNvPr id="13" name="Oval 12">
+            <a:extLst>
+              <a:ext uri="{FF2B5EF4-FFF2-40B4-BE49-F238E27FC236}">
+                <a16:creationId xmlns:a16="http://schemas.microsoft.com/office/drawing/2014/main" id="{E421327E-452A-CD40-9CB2-DCE4DADC7EB8}"/>
+              </a:ext>
+            </a:extLst>
+          </p:cNvPr>
+          <p:cNvSpPr/>
+          <p:nvPr/>
+        </p:nvSpPr>
+        <p:spPr>
+          <a:xfrm rot="20764211">
+            <a:off x="1270899" y="4637079"/>
+            <a:ext cx="865164" cy="326542"/>
+          </a:xfrm>
+          <a:prstGeom prst="ellipse">
+            <a:avLst/>
+          </a:prstGeom>
+          <a:noFill/>
+          <a:ln w="9525">
+            <a:solidFill>
+              <a:srgbClr val="FF0000"/>
+            </a:solidFill>
+            <a:prstDash val="dash"/>
+          </a:ln>
+        </p:spPr>
+        <p:style>
+          <a:lnRef idx="2">
+            <a:schemeClr val="accent1">
+              <a:shade val="50000"/>
+            </a:schemeClr>
+          </a:lnRef>
+          <a:fillRef idx="1">
+            <a:schemeClr val="accent1"/>
+          </a:fillRef>
+          <a:effectRef idx="0">
+            <a:schemeClr val="accent1"/>
+          </a:effectRef>
+          <a:fontRef idx="minor">
+            <a:schemeClr val="lt1"/>
+          </a:fontRef>
+        </p:style>
+        <p:txBody>
+          <a:bodyPr rtlCol="0" anchor="ctr"/>
+          <a:lstStyle/>
+          <a:p>
+            <a:pPr algn="ctr"/>
+            <a:endParaRPr lang="en-US"/>
+          </a:p>
+        </p:txBody>
+      </p:sp>
+      <p:sp>
+        <p:nvSpPr>
+          <p:cNvPr id="14" name="Oval 13">
+            <a:extLst>
+              <a:ext uri="{FF2B5EF4-FFF2-40B4-BE49-F238E27FC236}">
+                <a16:creationId xmlns:a16="http://schemas.microsoft.com/office/drawing/2014/main" id="{1DAD5DDC-8234-0745-83AA-125A34ABC016}"/>
+              </a:ext>
+            </a:extLst>
+          </p:cNvPr>
+          <p:cNvSpPr/>
+          <p:nvPr/>
+        </p:nvSpPr>
+        <p:spPr>
+          <a:xfrm rot="20764211">
+            <a:off x="5332359" y="2021240"/>
+            <a:ext cx="865164" cy="326542"/>
+          </a:xfrm>
+          <a:prstGeom prst="ellipse">
+            <a:avLst/>
+          </a:prstGeom>
+          <a:noFill/>
+          <a:ln w="9525">
+            <a:solidFill>
+              <a:srgbClr val="FF0000"/>
+            </a:solidFill>
+            <a:prstDash val="dash"/>
+          </a:ln>
+        </p:spPr>
+        <p:style>
+          <a:lnRef idx="2">
+            <a:schemeClr val="accent1">
+              <a:shade val="50000"/>
+            </a:schemeClr>
+          </a:lnRef>
+          <a:fillRef idx="1">
+            <a:schemeClr val="accent1"/>
+          </a:fillRef>
+          <a:effectRef idx="0">
+            <a:schemeClr val="accent1"/>
+          </a:effectRef>
+          <a:fontRef idx="minor">
+            <a:schemeClr val="lt1"/>
+          </a:fontRef>
+        </p:style>
+        <p:txBody>
+          <a:bodyPr rtlCol="0" anchor="ctr"/>
+          <a:lstStyle/>
+          <a:p>
+            <a:pPr algn="ctr"/>
+            <a:endParaRPr lang="en-US"/>
+          </a:p>
+        </p:txBody>
+      </p:sp>
+      <p:sp>
+        <p:nvSpPr>
+          <p:cNvPr id="15" name="Oval 14">
+            <a:extLst>
+              <a:ext uri="{FF2B5EF4-FFF2-40B4-BE49-F238E27FC236}">
+                <a16:creationId xmlns:a16="http://schemas.microsoft.com/office/drawing/2014/main" id="{08A2940A-50E2-9E4E-B45B-7E8B51C98C89}"/>
+              </a:ext>
+            </a:extLst>
+          </p:cNvPr>
+          <p:cNvSpPr/>
+          <p:nvPr/>
+        </p:nvSpPr>
+        <p:spPr>
+          <a:xfrm rot="21257093">
+            <a:off x="1828726" y="3163471"/>
+            <a:ext cx="3824834" cy="642507"/>
+          </a:xfrm>
+          <a:prstGeom prst="ellipse">
+            <a:avLst/>
+          </a:prstGeom>
+          <a:noFill/>
+          <a:ln w="9525">
+            <a:solidFill>
+              <a:srgbClr val="FF0000"/>
+            </a:solidFill>
+            <a:prstDash val="dash"/>
+          </a:ln>
+        </p:spPr>
+        <p:style>
+          <a:lnRef idx="2">
+            <a:schemeClr val="accent1">
+              <a:shade val="50000"/>
+            </a:schemeClr>
+          </a:lnRef>
+          <a:fillRef idx="1">
+            <a:schemeClr val="accent1"/>
+          </a:fillRef>
+          <a:effectRef idx="0">
+            <a:schemeClr val="accent1"/>
+          </a:effectRef>
+          <a:fontRef idx="minor">
+            <a:schemeClr val="lt1"/>
+          </a:fontRef>
+        </p:style>
+        <p:txBody>
+          <a:bodyPr rtlCol="0" anchor="ctr"/>
+          <a:lstStyle/>
+          <a:p>
+            <a:pPr algn="ctr"/>
+            <a:endParaRPr lang="en-US"/>
           </a:p>
         </p:txBody>
       </p:sp>
@@ -9072,6 +9838,157 @@
     <p:extLst>
       <p:ext uri="{BB962C8B-B14F-4D97-AF65-F5344CB8AC3E}">
         <p14:creationId xmlns:p14="http://schemas.microsoft.com/office/powerpoint/2010/main" val="1936291726"/>
+      </p:ext>
+    </p:extLst>
+  </p:cSld>
+  <p:clrMapOvr>
+    <a:masterClrMapping/>
+  </p:clrMapOvr>
+</p:sld>
+</file>
+
+<file path=ppt/slides/slide12.xml><?xml version="1.0" encoding="utf-8"?>
+<p:sld xmlns:a="http://schemas.openxmlformats.org/drawingml/2006/main" xmlns:r="http://schemas.openxmlformats.org/officeDocument/2006/relationships" xmlns:p="http://schemas.openxmlformats.org/presentationml/2006/main">
+  <p:cSld>
+    <p:spTree>
+      <p:nvGrpSpPr>
+        <p:cNvPr id="1" name=""/>
+        <p:cNvGrpSpPr/>
+        <p:nvPr/>
+      </p:nvGrpSpPr>
+      <p:grpSpPr>
+        <a:xfrm>
+          <a:off x="0" y="0"/>
+          <a:ext cx="0" cy="0"/>
+          <a:chOff x="0" y="0"/>
+          <a:chExt cx="0" cy="0"/>
+        </a:xfrm>
+      </p:grpSpPr>
+      <p:pic>
+        <p:nvPicPr>
+          <p:cNvPr id="4" name="Picture 3">
+            <a:extLst>
+              <a:ext uri="{FF2B5EF4-FFF2-40B4-BE49-F238E27FC236}">
+                <a16:creationId xmlns:a16="http://schemas.microsoft.com/office/drawing/2014/main" id="{61BBB3A3-78CA-A200-3731-AABEB7DD0C3F}"/>
+              </a:ext>
+            </a:extLst>
+          </p:cNvPr>
+          <p:cNvPicPr>
+            <a:picLocks noChangeAspect="1"/>
+          </p:cNvPicPr>
+          <p:nvPr/>
+        </p:nvPicPr>
+        <p:blipFill rotWithShape="1">
+          <a:blip r:embed="rId3"/>
+          <a:srcRect t="4855"/>
+          <a:stretch/>
+        </p:blipFill>
+        <p:spPr>
+          <a:xfrm>
+            <a:off x="3230245" y="719667"/>
+            <a:ext cx="5731510" cy="5710025"/>
+          </a:xfrm>
+          <a:prstGeom prst="rect">
+            <a:avLst/>
+          </a:prstGeom>
+        </p:spPr>
+      </p:pic>
+      <p:sp>
+        <p:nvSpPr>
+          <p:cNvPr id="2" name="TextBox 1">
+            <a:extLst>
+              <a:ext uri="{FF2B5EF4-FFF2-40B4-BE49-F238E27FC236}">
+                <a16:creationId xmlns:a16="http://schemas.microsoft.com/office/drawing/2014/main" id="{FAC75DAA-4E26-9941-B0F2-5BE6D09F93CE}"/>
+              </a:ext>
+            </a:extLst>
+          </p:cNvPr>
+          <p:cNvSpPr txBox="1"/>
+          <p:nvPr/>
+        </p:nvSpPr>
+        <p:spPr>
+          <a:xfrm>
+            <a:off x="4944535" y="3124201"/>
+            <a:ext cx="2142066" cy="523220"/>
+          </a:xfrm>
+          <a:prstGeom prst="rect">
+            <a:avLst/>
+          </a:prstGeom>
+          <a:noFill/>
+        </p:spPr>
+        <p:txBody>
+          <a:bodyPr wrap="square" rtlCol="0">
+            <a:spAutoFit/>
+          </a:bodyPr>
+          <a:lstStyle/>
+          <a:p>
+            <a:pPr algn="ctr"/>
+            <a:r>
+              <a:rPr lang="en-US" sz="1400" i="1" dirty="0">
+                <a:latin typeface="Arial" panose="020B0604020202020204" pitchFamily="34" charset="0"/>
+                <a:cs typeface="Arial" panose="020B0604020202020204" pitchFamily="34" charset="0"/>
+              </a:rPr>
+              <a:t>Blattabacterium cuenoti </a:t>
+            </a:r>
+            <a:r>
+              <a:rPr lang="en-US" sz="1400" dirty="0">
+                <a:latin typeface="Arial" panose="020B0604020202020204" pitchFamily="34" charset="0"/>
+                <a:cs typeface="Arial" panose="020B0604020202020204" pitchFamily="34" charset="0"/>
+              </a:rPr>
+              <a:t>genome </a:t>
+            </a:r>
+          </a:p>
+        </p:txBody>
+      </p:sp>
+      <p:sp>
+        <p:nvSpPr>
+          <p:cNvPr id="5" name="TextBox 4">
+            <a:extLst>
+              <a:ext uri="{FF2B5EF4-FFF2-40B4-BE49-F238E27FC236}">
+                <a16:creationId xmlns:a16="http://schemas.microsoft.com/office/drawing/2014/main" id="{1A655766-8F62-3C48-830A-8A34D4AC274A}"/>
+              </a:ext>
+            </a:extLst>
+          </p:cNvPr>
+          <p:cNvSpPr txBox="1"/>
+          <p:nvPr/>
+        </p:nvSpPr>
+        <p:spPr>
+          <a:xfrm>
+            <a:off x="4351868" y="523443"/>
+            <a:ext cx="3191932" cy="307777"/>
+          </a:xfrm>
+          <a:prstGeom prst="rect">
+            <a:avLst/>
+          </a:prstGeom>
+          <a:noFill/>
+        </p:spPr>
+        <p:txBody>
+          <a:bodyPr wrap="square" rtlCol="0">
+            <a:spAutoFit/>
+          </a:bodyPr>
+          <a:lstStyle/>
+          <a:p>
+            <a:pPr algn="ctr"/>
+            <a:r>
+              <a:rPr lang="en-US" sz="1400" i="1" dirty="0">
+                <a:latin typeface="Arial" panose="020B0604020202020204" pitchFamily="34" charset="0"/>
+                <a:cs typeface="Arial" panose="020B0604020202020204" pitchFamily="34" charset="0"/>
+              </a:rPr>
+              <a:t>Panesthia tryoni tegminifera </a:t>
+            </a:r>
+            <a:r>
+              <a:rPr lang="en-US" sz="1400" dirty="0">
+                <a:latin typeface="Arial" panose="020B0604020202020204" pitchFamily="34" charset="0"/>
+                <a:cs typeface="Arial" panose="020B0604020202020204" pitchFamily="34" charset="0"/>
+              </a:rPr>
+              <a:t>contig</a:t>
+            </a:r>
+          </a:p>
+        </p:txBody>
+      </p:sp>
+    </p:spTree>
+    <p:extLst>
+      <p:ext uri="{BB962C8B-B14F-4D97-AF65-F5344CB8AC3E}">
+        <p14:creationId xmlns:p14="http://schemas.microsoft.com/office/powerpoint/2010/main" val="1535606113"/>
       </p:ext>
     </p:extLst>
   </p:cSld>
@@ -9218,7 +10135,7 @@
                 <a:latin typeface="Arial" panose="020B0604020202020204" pitchFamily="34" charset="0"/>
                 <a:cs typeface="Arial" panose="020B0604020202020204" pitchFamily="34" charset="0"/>
               </a:rPr>
-              <a:t>Panesthia gigantea</a:t>
+              <a:t>Parapanesthia gigantea</a:t>
             </a:r>
             <a:endParaRPr lang="en-US" sz="1400" dirty="0">
               <a:latin typeface="Arial" panose="020B0604020202020204" pitchFamily="34" charset="0"/>
@@ -14119,8 +15036,8 @@
         </p:nvCxnSpPr>
         <p:spPr>
           <a:xfrm>
-            <a:off x="6830431" y="1456582"/>
-            <a:ext cx="1872000" cy="0"/>
+            <a:off x="7184393" y="1441834"/>
+            <a:ext cx="1512000" cy="0"/>
           </a:xfrm>
           <a:prstGeom prst="line">
             <a:avLst/>
@@ -15014,7 +15931,7 @@
                 <a:latin typeface="Arial" panose="020B0604020202020204" pitchFamily="34" charset="0"/>
                 <a:cs typeface="Arial" panose="020B0604020202020204" pitchFamily="34" charset="0"/>
               </a:rPr>
-              <a:t>Panesthia gigantea</a:t>
+              <a:t>Parapanesthia gigantea</a:t>
             </a:r>
             <a:endParaRPr lang="en-US" sz="1400" dirty="0">
               <a:latin typeface="Arial" panose="020B0604020202020204" pitchFamily="34" charset="0"/>
@@ -19915,8 +20832,8 @@
         </p:nvCxnSpPr>
         <p:spPr>
           <a:xfrm>
-            <a:off x="6830431" y="1456582"/>
-            <a:ext cx="1872000" cy="0"/>
+            <a:off x="7199140" y="1441834"/>
+            <a:ext cx="1512000" cy="0"/>
           </a:xfrm>
           <a:prstGeom prst="line">
             <a:avLst/>
@@ -20939,10 +21856,10 @@
       </p:grpSpPr>
       <p:pic>
         <p:nvPicPr>
-          <p:cNvPr id="12" name="Picture 11">
-            <a:extLst>
-              <a:ext uri="{FF2B5EF4-FFF2-40B4-BE49-F238E27FC236}">
-                <a16:creationId xmlns:a16="http://schemas.microsoft.com/office/drawing/2014/main" id="{8333BA2C-1347-6CF7-C733-4204EF41CFA7}"/>
+          <p:cNvPr id="4" name="Picture 3">
+            <a:extLst>
+              <a:ext uri="{FF2B5EF4-FFF2-40B4-BE49-F238E27FC236}">
+                <a16:creationId xmlns:a16="http://schemas.microsoft.com/office/drawing/2014/main" id="{78AC1BD0-7DA5-E9BF-1323-A48980C680F0}"/>
               </a:ext>
             </a:extLst>
           </p:cNvPr>
@@ -20959,183 +21876,18 @@
         </p:blipFill>
         <p:spPr>
           <a:xfrm>
-            <a:off x="38969" y="425302"/>
-            <a:ext cx="6579796" cy="4372700"/>
+            <a:off x="3699510" y="-103505"/>
+            <a:ext cx="4617303" cy="6806057"/>
           </a:xfrm>
           <a:prstGeom prst="rect">
             <a:avLst/>
           </a:prstGeom>
         </p:spPr>
       </p:pic>
-      <p:sp>
-        <p:nvSpPr>
-          <p:cNvPr id="5" name="TextBox 4">
-            <a:extLst>
-              <a:ext uri="{FF2B5EF4-FFF2-40B4-BE49-F238E27FC236}">
-                <a16:creationId xmlns:a16="http://schemas.microsoft.com/office/drawing/2014/main" id="{4F756E17-FE9E-4DC6-F3CF-AABBBF0B49DD}"/>
-              </a:ext>
-            </a:extLst>
-          </p:cNvPr>
-          <p:cNvSpPr txBox="1"/>
-          <p:nvPr/>
-        </p:nvSpPr>
-        <p:spPr>
-          <a:xfrm>
-            <a:off x="7856065" y="3519340"/>
-            <a:ext cx="3343468" cy="830997"/>
-          </a:xfrm>
-          <a:prstGeom prst="rect">
-            <a:avLst/>
-          </a:prstGeom>
-          <a:noFill/>
-        </p:spPr>
-        <p:txBody>
-          <a:bodyPr wrap="square" rtlCol="0">
-            <a:spAutoFit/>
-          </a:bodyPr>
-          <a:lstStyle/>
-          <a:p>
-            <a:pPr algn="ctr"/>
-            <a:r>
-              <a:rPr lang="en-US" sz="1600" b="1" dirty="0">
-                <a:solidFill>
-                  <a:srgbClr val="FF0000"/>
-                </a:solidFill>
-              </a:rPr>
-              <a:t>C. </a:t>
-            </a:r>
-            <a:r>
-              <a:rPr lang="en-US" sz="1600" dirty="0">
-                <a:solidFill>
-                  <a:srgbClr val="FF0000"/>
-                </a:solidFill>
-              </a:rPr>
-              <a:t>Placeholder: depiction of the origin of the insert around the </a:t>
-            </a:r>
-            <a:r>
-              <a:rPr lang="en-US" sz="1600" dirty="0" err="1">
-                <a:solidFill>
-                  <a:srgbClr val="FF0000"/>
-                </a:solidFill>
-              </a:rPr>
-              <a:t>Blatta</a:t>
-            </a:r>
-            <a:r>
-              <a:rPr lang="en-US" sz="1600" dirty="0">
-                <a:solidFill>
-                  <a:srgbClr val="FF0000"/>
-                </a:solidFill>
-              </a:rPr>
-              <a:t> genome (waiting on Leo)</a:t>
-            </a:r>
-          </a:p>
-        </p:txBody>
-      </p:sp>
-      <p:sp>
-        <p:nvSpPr>
-          <p:cNvPr id="7" name="TextBox 6">
-            <a:extLst>
-              <a:ext uri="{FF2B5EF4-FFF2-40B4-BE49-F238E27FC236}">
-                <a16:creationId xmlns:a16="http://schemas.microsoft.com/office/drawing/2014/main" id="{1C0E847B-8FC5-0867-7196-259B77611FF8}"/>
-              </a:ext>
-            </a:extLst>
-          </p:cNvPr>
-          <p:cNvSpPr txBox="1"/>
-          <p:nvPr/>
-        </p:nvSpPr>
-        <p:spPr>
-          <a:xfrm>
-            <a:off x="215683" y="425302"/>
-            <a:ext cx="324128" cy="369332"/>
-          </a:xfrm>
-          <a:prstGeom prst="rect">
-            <a:avLst/>
-          </a:prstGeom>
-          <a:noFill/>
-        </p:spPr>
-        <p:txBody>
-          <a:bodyPr wrap="none" rtlCol="0">
-            <a:spAutoFit/>
-          </a:bodyPr>
-          <a:lstStyle/>
-          <a:p>
-            <a:r>
-              <a:rPr lang="en-US" b="1" dirty="0"/>
-              <a:t>A</a:t>
-            </a:r>
-          </a:p>
-        </p:txBody>
-      </p:sp>
-      <p:pic>
-        <p:nvPicPr>
-          <p:cNvPr id="13" name="Picture 12">
-            <a:extLst>
-              <a:ext uri="{FF2B5EF4-FFF2-40B4-BE49-F238E27FC236}">
-                <a16:creationId xmlns:a16="http://schemas.microsoft.com/office/drawing/2014/main" id="{DC883A01-AA48-044E-76DC-460544A87194}"/>
-              </a:ext>
-            </a:extLst>
-          </p:cNvPr>
-          <p:cNvPicPr>
-            <a:picLocks noChangeAspect="1"/>
-          </p:cNvPicPr>
-          <p:nvPr/>
-        </p:nvPicPr>
-        <p:blipFill>
-          <a:blip r:embed="rId4"/>
-          <a:srcRect t="5172"/>
-          <a:stretch>
-            <a:fillRect/>
-          </a:stretch>
-        </p:blipFill>
-        <p:spPr>
-          <a:xfrm>
-            <a:off x="7048374" y="496730"/>
-            <a:ext cx="5104657" cy="2587255"/>
-          </a:xfrm>
-          <a:prstGeom prst="rect">
-            <a:avLst/>
-          </a:prstGeom>
-        </p:spPr>
-      </p:pic>
-      <p:sp>
-        <p:nvSpPr>
-          <p:cNvPr id="14" name="TextBox 13">
-            <a:extLst>
-              <a:ext uri="{FF2B5EF4-FFF2-40B4-BE49-F238E27FC236}">
-                <a16:creationId xmlns:a16="http://schemas.microsoft.com/office/drawing/2014/main" id="{2C6B5942-B39C-46A8-0714-63EF48E22894}"/>
-              </a:ext>
-            </a:extLst>
-          </p:cNvPr>
-          <p:cNvSpPr txBox="1"/>
-          <p:nvPr/>
-        </p:nvSpPr>
-        <p:spPr>
-          <a:xfrm>
-            <a:off x="6720534" y="425302"/>
-            <a:ext cx="314510" cy="369332"/>
-          </a:xfrm>
-          <a:prstGeom prst="rect">
-            <a:avLst/>
-          </a:prstGeom>
-          <a:noFill/>
-        </p:spPr>
-        <p:txBody>
-          <a:bodyPr wrap="none" rtlCol="0">
-            <a:spAutoFit/>
-          </a:bodyPr>
-          <a:lstStyle/>
-          <a:p>
-            <a:r>
-              <a:rPr lang="en-US" b="1" dirty="0"/>
-              <a:t>B</a:t>
-            </a:r>
-          </a:p>
-        </p:txBody>
-      </p:sp>
     </p:spTree>
     <p:extLst>
       <p:ext uri="{BB962C8B-B14F-4D97-AF65-F5344CB8AC3E}">
-        <p14:creationId xmlns:p14="http://schemas.microsoft.com/office/powerpoint/2010/main" val="2560380269"/>
+        <p14:creationId xmlns:p14="http://schemas.microsoft.com/office/powerpoint/2010/main" val="4199959309"/>
       </p:ext>
     </p:extLst>
   </p:cSld>
@@ -21167,7 +21919,7 @@
           <p:cNvPr id="4" name="Picture 3">
             <a:extLst>
               <a:ext uri="{FF2B5EF4-FFF2-40B4-BE49-F238E27FC236}">
-                <a16:creationId xmlns:a16="http://schemas.microsoft.com/office/drawing/2014/main" id="{78AC1BD0-7DA5-E9BF-1323-A48980C680F0}"/>
+                <a16:creationId xmlns:a16="http://schemas.microsoft.com/office/drawing/2014/main" id="{61BBB3A3-78CA-A200-3731-AABEB7DD0C3F}"/>
               </a:ext>
             </a:extLst>
           </p:cNvPr>
@@ -21184,8 +21936,8 @@
         </p:blipFill>
         <p:spPr>
           <a:xfrm>
-            <a:off x="3699510" y="-103505"/>
-            <a:ext cx="4617303" cy="6806057"/>
+            <a:off x="3230245" y="428307"/>
+            <a:ext cx="5731510" cy="6001385"/>
           </a:xfrm>
           <a:prstGeom prst="rect">
             <a:avLst/>
@@ -21195,7 +21947,7 @@
     </p:spTree>
     <p:extLst>
       <p:ext uri="{BB962C8B-B14F-4D97-AF65-F5344CB8AC3E}">
-        <p14:creationId xmlns:p14="http://schemas.microsoft.com/office/powerpoint/2010/main" val="4199959309"/>
+        <p14:creationId xmlns:p14="http://schemas.microsoft.com/office/powerpoint/2010/main" val="2815334628"/>
       </p:ext>
     </p:extLst>
   </p:cSld>
@@ -21224,10 +21976,10 @@
       </p:grpSpPr>
       <p:pic>
         <p:nvPicPr>
-          <p:cNvPr id="4" name="Picture 3">
-            <a:extLst>
-              <a:ext uri="{FF2B5EF4-FFF2-40B4-BE49-F238E27FC236}">
-                <a16:creationId xmlns:a16="http://schemas.microsoft.com/office/drawing/2014/main" id="{61BBB3A3-78CA-A200-3731-AABEB7DD0C3F}"/>
+          <p:cNvPr id="5" name="Picture 4">
+            <a:extLst>
+              <a:ext uri="{FF2B5EF4-FFF2-40B4-BE49-F238E27FC236}">
+                <a16:creationId xmlns:a16="http://schemas.microsoft.com/office/drawing/2014/main" id="{3F65D913-7192-374F-8DD8-295EDAC76DD3}"/>
               </a:ext>
             </a:extLst>
           </p:cNvPr>
@@ -21237,25 +21989,84 @@
           <p:nvPr/>
         </p:nvPicPr>
         <p:blipFill>
-          <a:blip r:embed="rId3"/>
+          <a:blip r:embed="rId2"/>
           <a:stretch>
             <a:fillRect/>
           </a:stretch>
         </p:blipFill>
         <p:spPr>
           <a:xfrm>
-            <a:off x="3230245" y="428307"/>
-            <a:ext cx="5731510" cy="6001385"/>
+            <a:off x="1689107" y="211874"/>
+            <a:ext cx="8985383" cy="6276794"/>
           </a:xfrm>
           <a:prstGeom prst="rect">
             <a:avLst/>
           </a:prstGeom>
         </p:spPr>
       </p:pic>
+      <p:sp>
+        <p:nvSpPr>
+          <p:cNvPr id="6" name="TextBox 5">
+            <a:extLst>
+              <a:ext uri="{FF2B5EF4-FFF2-40B4-BE49-F238E27FC236}">
+                <a16:creationId xmlns:a16="http://schemas.microsoft.com/office/drawing/2014/main" id="{4247A41C-BF5A-F64D-ABE3-09583767864B}"/>
+              </a:ext>
+            </a:extLst>
+          </p:cNvPr>
+          <p:cNvSpPr txBox="1"/>
+          <p:nvPr/>
+        </p:nvSpPr>
+        <p:spPr>
+          <a:xfrm>
+            <a:off x="624468" y="6488668"/>
+            <a:ext cx="3591689" cy="369332"/>
+          </a:xfrm>
+          <a:prstGeom prst="rect">
+            <a:avLst/>
+          </a:prstGeom>
+          <a:noFill/>
+        </p:spPr>
+        <p:txBody>
+          <a:bodyPr wrap="none" rtlCol="0">
+            <a:spAutoFit/>
+          </a:bodyPr>
+          <a:lstStyle/>
+          <a:p>
+            <a:r>
+              <a:rPr lang="en-US" dirty="0"/>
+              <a:t>P-</a:t>
+            </a:r>
+            <a:r>
+              <a:rPr lang="en-US" dirty="0" err="1"/>
+              <a:t>tryoni</a:t>
+            </a:r>
+            <a:r>
+              <a:rPr lang="en-US" dirty="0"/>
+              <a:t>-</a:t>
+            </a:r>
+            <a:r>
+              <a:rPr lang="en-US" dirty="0" err="1"/>
+              <a:t>tryoni</a:t>
+            </a:r>
+            <a:r>
+              <a:rPr lang="en-US" dirty="0"/>
+              <a:t>-</a:t>
+            </a:r>
+            <a:r>
+              <a:rPr lang="en-US" dirty="0" err="1"/>
+              <a:t>Eungella_ageing</a:t>
+            </a:r>
+            <a:r>
+              <a:rPr lang="en-US" dirty="0"/>
+              <a:t>-plot</a:t>
+            </a:r>
+          </a:p>
+        </p:txBody>
+      </p:sp>
     </p:spTree>
     <p:extLst>
       <p:ext uri="{BB962C8B-B14F-4D97-AF65-F5344CB8AC3E}">
-        <p14:creationId xmlns:p14="http://schemas.microsoft.com/office/powerpoint/2010/main" val="2815334628"/>
+        <p14:creationId xmlns:p14="http://schemas.microsoft.com/office/powerpoint/2010/main" val="82245517"/>
       </p:ext>
     </p:extLst>
   </p:cSld>

</xml_diff>